<commit_message>
Realign chalkboard card (proposal B) on a shared grid
Both faces now share margins, a right column, the divider line and the
bottom row; courses text no longer clips. Adds the PDF export.

Co-Authored-By: Claude Opus 5.5 <noreply@anthropic.com>
Claude-Session: https://claude.ai/code/session_01ASinA93KsyzmhBdhUk8dLe
</commit_message>
<xml_diff>
--- a/tarjeta-clases/propuesta-B-powerpoint/tarjeta-pizarra.pptx
+++ b/tarjeta-clases/propuesta-B-powerpoint/tarjeta-pizarra.pptx
@@ -971,9 +971,9 @@
           <p:nvPr/>
         </p:nvSpPr>
         <p:spPr>
-          <a:xfrm rot="-360000">
-            <a:off x="1872000" y="216000"/>
-            <a:ext cx="1080000" cy="216000"/>
+          <a:xfrm rot="-300000">
+            <a:off x="1800000" y="223200"/>
+            <a:ext cx="792000" cy="180000"/>
           </a:xfrm>
           <a:prstGeom prst="rect">
             <a:avLst/>
@@ -989,10 +989,10 @@
               <a:buNone/>
             </a:pPr>
             <a:r>
-              <a:rPr lang="en-US" sz="900" i="1" dirty="0">
+              <a:rPr lang="en-US" sz="800" i="1" dirty="0">
                 <a:solidFill>
                   <a:srgbClr val="F2F0E6">
-                    <a:alpha val="18000"/>
+                    <a:alpha val="20000"/>
                   </a:srgbClr>
                 </a:solidFill>
                 <a:latin typeface="Century Schoolbook" pitchFamily="34" charset="0"/>
@@ -1001,20 +1001,20 @@
               </a:rPr>
               <a:t>F = m·a</a:t>
             </a:r>
-            <a:endParaRPr lang="en-US" sz="900" dirty="0"/>
-          </a:p>
-        </p:txBody>
-      </p:sp>
-      <p:sp>
-        <p:nvSpPr>
-          <p:cNvPr id="3" name="formula Δx/Δt"/>
+            <a:endParaRPr lang="en-US" sz="800" dirty="0"/>
+          </a:p>
+        </p:txBody>
+      </p:sp>
+      <p:sp>
+        <p:nvSpPr>
+          <p:cNvPr id="3" name="formula Δx / Δt"/>
           <p:cNvSpPr txBox="1"/>
           <p:nvPr/>
         </p:nvSpPr>
         <p:spPr>
           <a:xfrm rot="240000">
-            <a:off x="2664000" y="1296000"/>
-            <a:ext cx="1080000" cy="216000"/>
+            <a:off x="2520000" y="1116000"/>
+            <a:ext cx="792000" cy="180000"/>
           </a:xfrm>
           <a:prstGeom prst="rect">
             <a:avLst/>
@@ -1033,14 +1033,14 @@
               <a:rPr lang="en-US" sz="800" i="1" dirty="0">
                 <a:solidFill>
                   <a:srgbClr val="F2F0E6">
-                    <a:alpha val="18000"/>
+                    <a:alpha val="20000"/>
                   </a:srgbClr>
                 </a:solidFill>
                 <a:latin typeface="Century Schoolbook" pitchFamily="34" charset="0"/>
                 <a:ea typeface="Century Schoolbook" pitchFamily="34" charset="-122"/>
                 <a:cs typeface="Century Schoolbook" pitchFamily="34" charset="-120"/>
               </a:rPr>
-              <a:t>Δx/Δt</a:t>
+              <a:t>Δx / Δt</a:t>
             </a:r>
             <a:endParaRPr lang="en-US" sz="800" dirty="0"/>
           </a:p>
@@ -1048,14 +1048,14 @@
       </p:sp>
       <p:sp>
         <p:nvSpPr>
-          <p:cNvPr id="4" name="formula a² + b² = c²"/>
+          <p:cNvPr id="4" name="formula ∫ f(x) dx"/>
           <p:cNvSpPr txBox="1"/>
           <p:nvPr/>
         </p:nvSpPr>
         <p:spPr>
           <a:xfrm rot="-180000">
-            <a:off x="1440000" y="1332000"/>
-            <a:ext cx="1080000" cy="216000"/>
+            <a:off x="2304000" y="1339200"/>
+            <a:ext cx="792000" cy="180000"/>
           </a:xfrm>
           <a:prstGeom prst="rect">
             <a:avLst/>
@@ -1074,14 +1074,14 @@
               <a:rPr lang="en-US" sz="700" i="1" dirty="0">
                 <a:solidFill>
                   <a:srgbClr val="F2F0E6">
-                    <a:alpha val="18000"/>
+                    <a:alpha val="20000"/>
                   </a:srgbClr>
                 </a:solidFill>
                 <a:latin typeface="Century Schoolbook" pitchFamily="34" charset="0"/>
                 <a:ea typeface="Century Schoolbook" pitchFamily="34" charset="-122"/>
                 <a:cs typeface="Century Schoolbook" pitchFamily="34" charset="-120"/>
               </a:rPr>
-              <a:t>a² + b² = c²</a:t>
+              <a:t>∫ f(x) dx</a:t>
             </a:r>
             <a:endParaRPr lang="en-US" sz="700" dirty="0"/>
           </a:p>
@@ -1089,14 +1089,14 @@
       </p:sp>
       <p:sp>
         <p:nvSpPr>
-          <p:cNvPr id="5" name="formula ∫ f(x) dx"/>
+          <p:cNvPr id="5" name="servicio"/>
           <p:cNvSpPr txBox="1"/>
           <p:nvPr/>
         </p:nvSpPr>
         <p:spPr>
-          <a:xfrm rot="360000">
-            <a:off x="2016000" y="90000"/>
-            <a:ext cx="1080000" cy="216000"/>
+          <a:xfrm>
+            <a:off x="252000" y="252000"/>
+            <a:ext cx="1440000" cy="126000"/>
           </a:xfrm>
           <a:prstGeom prst="rect">
             <a:avLst/>
@@ -1105,24 +1105,19 @@
           <a:ln/>
         </p:spPr>
         <p:txBody>
-          <a:bodyPr wrap="square" lIns="0" tIns="0" rIns="0" bIns="0" rtlCol="0" anchor="ctr"/>
+          <a:bodyPr wrap="square" lIns="0" tIns="0" rIns="0" bIns="0" rtlCol="0" anchor="t"/>
           <a:lstStyle/>
           <a:p>
             <a:pPr indent="0" marL="0">
               <a:buNone/>
             </a:pPr>
             <a:r>
-              <a:rPr lang="en-US" sz="700" i="1" dirty="0">
-                <a:solidFill>
-                  <a:srgbClr val="F2F0E6">
-                    <a:alpha val="18000"/>
-                  </a:srgbClr>
-                </a:solidFill>
-                <a:latin typeface="Century Schoolbook" pitchFamily="34" charset="0"/>
-                <a:ea typeface="Century Schoolbook" pitchFamily="34" charset="-122"/>
-                <a:cs typeface="Century Schoolbook" pitchFamily="34" charset="-120"/>
-              </a:rPr>
-              <a:t>∫ f(x) dx</a:t>
+              <a:rPr lang="en-US" sz="700" b="1" dirty="0">
+                <a:solidFill>
+                  <a:srgbClr val="7FA796"/>
+                </a:solidFill>
+              </a:rPr>
+              <a:t>Clases particulares y grupales</a:t>
             </a:r>
             <a:endParaRPr lang="en-US" sz="700" dirty="0"/>
           </a:p>
@@ -1130,91 +1125,14 @@
       </p:sp>
       <p:sp>
         <p:nvSpPr>
-          <p:cNvPr id="6" name="formula pH = −log[H⁺]"/>
+          <p:cNvPr id="6" name="titular"/>
           <p:cNvSpPr txBox="1"/>
           <p:nvPr/>
         </p:nvSpPr>
         <p:spPr>
           <a:xfrm>
-            <a:off x="144000" y="90000"/>
-            <a:ext cx="1080000" cy="216000"/>
-          </a:xfrm>
-          <a:prstGeom prst="rect">
-            <a:avLst/>
-          </a:prstGeom>
-          <a:noFill/>
-          <a:ln/>
-        </p:spPr>
-        <p:txBody>
-          <a:bodyPr wrap="square" lIns="0" tIns="0" rIns="0" bIns="0" rtlCol="0" anchor="ctr"/>
-          <a:lstStyle/>
-          <a:p>
-            <a:pPr indent="0" marL="0">
-              <a:buNone/>
-            </a:pPr>
-            <a:r>
-              <a:rPr lang="en-US" sz="600" i="1" dirty="0">
-                <a:solidFill>
-                  <a:srgbClr val="F2F0E6">
-                    <a:alpha val="18000"/>
-                  </a:srgbClr>
-                </a:solidFill>
-                <a:latin typeface="Century Schoolbook" pitchFamily="34" charset="0"/>
-                <a:ea typeface="Century Schoolbook" pitchFamily="34" charset="-122"/>
-                <a:cs typeface="Century Schoolbook" pitchFamily="34" charset="-120"/>
-              </a:rPr>
-              <a:t>pH = −log[H⁺]</a:t>
-            </a:r>
-            <a:endParaRPr lang="en-US" sz="600" dirty="0"/>
-          </a:p>
-        </p:txBody>
-      </p:sp>
-      <p:sp>
-        <p:nvSpPr>
-          <p:cNvPr id="7" name="servicio"/>
-          <p:cNvSpPr txBox="1"/>
-          <p:nvPr/>
-        </p:nvSpPr>
-        <p:spPr>
-          <a:xfrm>
-            <a:off x="252000" y="324000"/>
-            <a:ext cx="2160000" cy="144000"/>
-          </a:xfrm>
-          <a:prstGeom prst="rect">
-            <a:avLst/>
-          </a:prstGeom>
-          <a:noFill/>
-          <a:ln/>
-        </p:spPr>
-        <p:txBody>
-          <a:bodyPr wrap="square" lIns="0" tIns="0" rIns="0" bIns="0" rtlCol="0" anchor="ctr"/>
-          <a:lstStyle/>
-          <a:p>
-            <a:pPr indent="0" marL="0">
-              <a:buNone/>
-            </a:pPr>
-            <a:r>
-              <a:rPr lang="en-US" sz="700" b="1" dirty="0">
-                <a:solidFill>
-                  <a:srgbClr val="7FA796"/>
-                </a:solidFill>
-              </a:rPr>
-              <a:t>Clases particulares y grupales</a:t>
-            </a:r>
-            <a:endParaRPr lang="en-US" sz="700" dirty="0"/>
-          </a:p>
-        </p:txBody>
-      </p:sp>
-      <p:sp>
-        <p:nvSpPr>
-          <p:cNvPr id="8" name="titular"/>
-          <p:cNvSpPr txBox="1"/>
-          <p:nvPr/>
-        </p:nvSpPr>
-        <p:spPr>
-          <a:xfrm>
-            <a:off x="252000" y="504000"/>
-            <a:ext cx="2160000" cy="720000"/>
+            <a:off x="252000" y="432000"/>
+            <a:ext cx="2016000" cy="648000"/>
           </a:xfrm>
           <a:prstGeom prst="rect">
             <a:avLst/>
@@ -1269,14 +1187,14 @@
       </p:sp>
       <p:sp>
         <p:nvSpPr>
-          <p:cNvPr id="9" name="x"/>
+          <p:cNvPr id="7" name="cursos"/>
           <p:cNvSpPr txBox="1"/>
           <p:nvPr/>
         </p:nvSpPr>
         <p:spPr>
           <a:xfrm>
-            <a:off x="2520000" y="486000"/>
-            <a:ext cx="648000" cy="612000"/>
+            <a:off x="252000" y="1152000"/>
+            <a:ext cx="2088000" cy="252000"/>
           </a:xfrm>
           <a:prstGeom prst="rect">
             <a:avLst/>
@@ -1285,36 +1203,57 @@
           <a:ln/>
         </p:spPr>
         <p:txBody>
-          <a:bodyPr wrap="square" lIns="0" tIns="0" rIns="0" bIns="0" rtlCol="0" anchor="ctr"/>
-          <a:lstStyle/>
-          <a:p>
-            <a:pPr algn="ctr" indent="0" marL="0">
-              <a:buNone/>
-            </a:pPr>
-            <a:r>
-              <a:rPr lang="en-US" sz="4000" i="1" dirty="0">
-                <a:solidFill>
-                  <a:srgbClr val="F3D34A"/>
-                </a:solidFill>
-                <a:latin typeface="Century Schoolbook" pitchFamily="34" charset="0"/>
-                <a:ea typeface="Century Schoolbook" pitchFamily="34" charset="-122"/>
-                <a:cs typeface="Century Schoolbook" pitchFamily="34" charset="-120"/>
-              </a:rPr>
-              <a:t>x</a:t>
-            </a:r>
-            <a:endParaRPr lang="en-US" sz="4000" dirty="0"/>
-          </a:p>
-        </p:txBody>
-      </p:sp>
-      <p:sp>
-        <p:nvSpPr>
-          <p:cNvPr id="10" name="circulo tiza"/>
+          <a:bodyPr wrap="square" lIns="0" tIns="0" rIns="0" bIns="0" rtlCol="0" anchor="t"/>
+          <a:lstStyle/>
+          <a:p>
+            <a:pPr indent="0" marL="0">
+              <a:lnSpc>
+                <a:spcPct val="105000"/>
+              </a:lnSpc>
+              <a:buNone/>
+            </a:pPr>
+            <a:r>
+              <a:rPr lang="en-US" sz="750" dirty="0">
+                <a:solidFill>
+                  <a:srgbClr val="F2F0E6">
+                    <a:alpha val="88000"/>
+                  </a:srgbClr>
+                </a:solidFill>
+              </a:rPr>
+              <a:t>Matemática, Física y Química</a:t>
+            </a:r>
+            <a:endParaRPr lang="en-US" sz="750" dirty="0"/>
+          </a:p>
+          <a:p>
+            <a:pPr indent="0" marL="0">
+              <a:lnSpc>
+                <a:spcPct val="105000"/>
+              </a:lnSpc>
+              <a:buNone/>
+            </a:pPr>
+            <a:r>
+              <a:rPr lang="en-US" sz="750" dirty="0">
+                <a:solidFill>
+                  <a:srgbClr val="F2F0E6">
+                    <a:alpha val="88000"/>
+                  </a:srgbClr>
+                </a:solidFill>
+              </a:rPr>
+              <a:t>Colegio, preuniversitario y universidad</a:t>
+            </a:r>
+            <a:endParaRPr lang="en-US" sz="750" dirty="0"/>
+          </a:p>
+        </p:txBody>
+      </p:sp>
+      <p:sp>
+        <p:nvSpPr>
+          <p:cNvPr id="8" name="circulo tiza"/>
           <p:cNvSpPr/>
           <p:nvPr/>
         </p:nvSpPr>
         <p:spPr>
           <a:xfrm rot="-480000">
-            <a:off x="2538000" y="522000"/>
+            <a:off x="2484000" y="486000"/>
             <a:ext cx="612000" cy="540000"/>
           </a:xfrm>
           <a:prstGeom prst="ellipse">
@@ -1330,14 +1269,14 @@
       </p:sp>
       <p:sp>
         <p:nvSpPr>
-          <p:cNvPr id="11" name="cursos"/>
+          <p:cNvPr id="9" name="x"/>
           <p:cNvSpPr txBox="1"/>
           <p:nvPr/>
         </p:nvSpPr>
         <p:spPr>
           <a:xfrm>
-            <a:off x="252000" y="1206000"/>
-            <a:ext cx="2016000" cy="252000"/>
+            <a:off x="2484000" y="450000"/>
+            <a:ext cx="612000" cy="540000"/>
           </a:xfrm>
           <a:prstGeom prst="rect">
             <a:avLst/>
@@ -1349,32 +1288,33 @@
           <a:bodyPr wrap="square" lIns="0" tIns="0" rIns="0" bIns="0" rtlCol="0" anchor="ctr"/>
           <a:lstStyle/>
           <a:p>
-            <a:pPr indent="0" marL="0">
-              <a:buNone/>
-            </a:pPr>
-            <a:r>
-              <a:rPr lang="en-US" sz="750" dirty="0">
-                <a:solidFill>
-                  <a:srgbClr val="F2F0E6">
-                    <a:alpha val="85000"/>
-                  </a:srgbClr>
-                </a:solidFill>
-              </a:rPr>
-              <a:t>Matemática, Física y Química para colegio, pre y universidad.</a:t>
-            </a:r>
-            <a:endParaRPr lang="en-US" sz="750" dirty="0"/>
-          </a:p>
-        </p:txBody>
-      </p:sp>
-      <p:sp>
-        <p:nvSpPr>
-          <p:cNvPr id="12" name="repisa"/>
+            <a:pPr algn="ctr" indent="0" marL="0">
+              <a:buNone/>
+            </a:pPr>
+            <a:r>
+              <a:rPr lang="en-US" sz="4000" i="1" dirty="0">
+                <a:solidFill>
+                  <a:srgbClr val="F3D34A"/>
+                </a:solidFill>
+                <a:latin typeface="Century Schoolbook" pitchFamily="34" charset="0"/>
+                <a:ea typeface="Century Schoolbook" pitchFamily="34" charset="-122"/>
+                <a:cs typeface="Century Schoolbook" pitchFamily="34" charset="-120"/>
+              </a:rPr>
+              <a:t>x</a:t>
+            </a:r>
+            <a:endParaRPr lang="en-US" sz="4000" dirty="0"/>
+          </a:p>
+        </p:txBody>
+      </p:sp>
+      <p:sp>
+        <p:nvSpPr>
+          <p:cNvPr id="10" name="repisa"/>
           <p:cNvSpPr/>
           <p:nvPr/>
         </p:nvSpPr>
         <p:spPr>
           <a:xfrm>
-            <a:off x="252000" y="1620000"/>
+            <a:off x="252000" y="1584000"/>
             <a:ext cx="2952000" cy="0"/>
           </a:xfrm>
           <a:prstGeom prst="line">
@@ -1391,13 +1331,13 @@
       </p:sp>
       <p:sp>
         <p:nvSpPr>
-          <p:cNvPr id="13" name="marca (pendiente)"/>
+          <p:cNvPr id="11" name="marca (pendiente)"/>
           <p:cNvSpPr txBox="1"/>
           <p:nvPr/>
         </p:nvSpPr>
         <p:spPr>
           <a:xfrm>
-            <a:off x="252000" y="1692000"/>
+            <a:off x="252000" y="1656000"/>
             <a:ext cx="1440000" cy="216000"/>
           </a:xfrm>
           <a:prstGeom prst="rect">
@@ -1430,14 +1370,14 @@
       </p:sp>
       <p:sp>
         <p:nvSpPr>
-          <p:cNvPr id="14" name="autoridad"/>
+          <p:cNvPr id="12" name="autoridad"/>
           <p:cNvSpPr txBox="1"/>
           <p:nvPr/>
         </p:nvSpPr>
         <p:spPr>
           <a:xfrm>
-            <a:off x="1656000" y="1735200"/>
-            <a:ext cx="1548000" cy="144000"/>
+            <a:off x="1656000" y="1656000"/>
+            <a:ext cx="1548000" cy="216000"/>
           </a:xfrm>
           <a:prstGeom prst="rect">
             <a:avLst/>
@@ -1505,7 +1445,7 @@
         <p:spPr>
           <a:xfrm>
             <a:off x="252000" y="252000"/>
-            <a:ext cx="1800000" cy="216000"/>
+            <a:ext cx="1980000" cy="198000"/>
           </a:xfrm>
           <a:prstGeom prst="rect">
             <a:avLst/>
@@ -1514,7 +1454,7 @@
           <a:ln/>
         </p:spPr>
         <p:txBody>
-          <a:bodyPr wrap="square" lIns="0" tIns="0" rIns="0" bIns="0" rtlCol="0" anchor="ctr"/>
+          <a:bodyPr wrap="square" lIns="0" tIns="0" rIns="0" bIns="0" rtlCol="0" anchor="t"/>
           <a:lstStyle/>
           <a:p>
             <a:pPr indent="0" marL="0">
@@ -1543,7 +1483,7 @@
         </p:nvSpPr>
         <p:spPr>
           <a:xfrm>
-            <a:off x="252000" y="558000"/>
+            <a:off x="252000" y="576000"/>
             <a:ext cx="158400" cy="158400"/>
           </a:xfrm>
           <a:prstGeom prst="ellipse">
@@ -1563,7 +1503,7 @@
         </p:nvSpPr>
         <p:spPr>
           <a:xfrm>
-            <a:off x="252000" y="558000"/>
+            <a:off x="252000" y="576000"/>
             <a:ext cx="158400" cy="158400"/>
           </a:xfrm>
           <a:prstGeom prst="rect">
@@ -1599,8 +1539,8 @@
         </p:nvSpPr>
         <p:spPr>
           <a:xfrm>
-            <a:off x="468000" y="547200"/>
-            <a:ext cx="1872000" cy="180000"/>
+            <a:off x="486000" y="543600"/>
+            <a:ext cx="1746000" cy="230400"/>
           </a:xfrm>
           <a:prstGeom prst="rect">
             <a:avLst/>
@@ -1613,6 +1553,9 @@
           <a:lstStyle/>
           <a:p>
             <a:pPr indent="0" marL="0">
+              <a:lnSpc>
+                <a:spcPct val="100000"/>
+              </a:lnSpc>
               <a:buNone/>
             </a:pPr>
             <a:r>
@@ -1621,9 +1564,15 @@
                   <a:srgbClr val="23443A"/>
                 </a:solidFill>
               </a:rPr>
-              <a:t>Diagnóstico: </a:t>
-            </a:r>
+              <a:t>Diagnóstico</a:t>
+            </a:r>
+            <a:endParaRPr lang="en-US" sz="700" dirty="0"/>
+          </a:p>
+          <a:p>
             <a:pPr indent="0" marL="0">
+              <a:lnSpc>
+                <a:spcPct val="100000"/>
+              </a:lnSpc>
               <a:buNone/>
             </a:pPr>
             <a:r>
@@ -1646,7 +1595,7 @@
         </p:nvSpPr>
         <p:spPr>
           <a:xfrm>
-            <a:off x="252000" y="810000"/>
+            <a:off x="252000" y="900000"/>
             <a:ext cx="158400" cy="158400"/>
           </a:xfrm>
           <a:prstGeom prst="ellipse">
@@ -1666,7 +1615,7 @@
         </p:nvSpPr>
         <p:spPr>
           <a:xfrm>
-            <a:off x="252000" y="810000"/>
+            <a:off x="252000" y="900000"/>
             <a:ext cx="158400" cy="158400"/>
           </a:xfrm>
           <a:prstGeom prst="rect">
@@ -1702,8 +1651,8 @@
         </p:nvSpPr>
         <p:spPr>
           <a:xfrm>
-            <a:off x="468000" y="799200"/>
-            <a:ext cx="1872000" cy="180000"/>
+            <a:off x="486000" y="867600"/>
+            <a:ext cx="1746000" cy="230400"/>
           </a:xfrm>
           <a:prstGeom prst="rect">
             <a:avLst/>
@@ -1716,6 +1665,9 @@
           <a:lstStyle/>
           <a:p>
             <a:pPr indent="0" marL="0">
+              <a:lnSpc>
+                <a:spcPct val="100000"/>
+              </a:lnSpc>
               <a:buNone/>
             </a:pPr>
             <a:r>
@@ -1724,9 +1676,15 @@
                   <a:srgbClr val="23443A"/>
                 </a:solidFill>
               </a:rPr>
-              <a:t>Plan semanal: </a:t>
-            </a:r>
+              <a:t>Plan semanal</a:t>
+            </a:r>
+            <a:endParaRPr lang="en-US" sz="700" dirty="0"/>
+          </a:p>
+          <a:p>
             <a:pPr indent="0" marL="0">
+              <a:lnSpc>
+                <a:spcPct val="100000"/>
+              </a:lnSpc>
               <a:buNone/>
             </a:pPr>
             <a:r>
@@ -1749,7 +1707,7 @@
         </p:nvSpPr>
         <p:spPr>
           <a:xfrm>
-            <a:off x="252000" y="1062000"/>
+            <a:off x="252000" y="1224000"/>
             <a:ext cx="158400" cy="158400"/>
           </a:xfrm>
           <a:prstGeom prst="ellipse">
@@ -1769,7 +1727,7 @@
         </p:nvSpPr>
         <p:spPr>
           <a:xfrm>
-            <a:off x="252000" y="1062000"/>
+            <a:off x="252000" y="1224000"/>
             <a:ext cx="158400" cy="158400"/>
           </a:xfrm>
           <a:prstGeom prst="rect">
@@ -1805,8 +1763,8 @@
         </p:nvSpPr>
         <p:spPr>
           <a:xfrm>
-            <a:off x="468000" y="1051200"/>
-            <a:ext cx="1872000" cy="180000"/>
+            <a:off x="486000" y="1191600"/>
+            <a:ext cx="1746000" cy="230400"/>
           </a:xfrm>
           <a:prstGeom prst="rect">
             <a:avLst/>
@@ -1819,6 +1777,9 @@
           <a:lstStyle/>
           <a:p>
             <a:pPr indent="0" marL="0">
+              <a:lnSpc>
+                <a:spcPct val="100000"/>
+              </a:lnSpc>
               <a:buNone/>
             </a:pPr>
             <a:r>
@@ -1827,9 +1788,15 @@
                   <a:srgbClr val="23443A"/>
                 </a:solidFill>
               </a:rPr>
-              <a:t>Seguimiento: </a:t>
-            </a:r>
+              <a:t>Seguimiento</a:t>
+            </a:r>
+            <a:endParaRPr lang="en-US" sz="700" dirty="0"/>
+          </a:p>
+          <a:p>
             <a:pPr indent="0" marL="0">
+              <a:lnSpc>
+                <a:spcPct val="100000"/>
+              </a:lnSpc>
               <a:buNone/>
             </a:pPr>
             <a:r>
@@ -1853,11 +1820,11 @@
         <p:spPr>
           <a:xfrm>
             <a:off x="2376000" y="252000"/>
-            <a:ext cx="828000" cy="612000"/>
+            <a:ext cx="828000" cy="540000"/>
           </a:xfrm>
           <a:prstGeom prst="roundRect">
             <a:avLst>
-              <a:gd name="adj" fmla="val 8965"/>
+              <a:gd name="adj" fmla="val 10160"/>
             </a:avLst>
           </a:prstGeom>
           <a:solidFill>
@@ -1874,8 +1841,8 @@
         </p:nvSpPr>
         <p:spPr>
           <a:xfrm>
-            <a:off x="2376000" y="280800"/>
-            <a:ext cx="828000" cy="554400"/>
+            <a:off x="2376000" y="252000"/>
+            <a:ext cx="828000" cy="540000"/>
           </a:xfrm>
           <a:prstGeom prst="rect">
             <a:avLst/>
@@ -1949,8 +1916,8 @@
         </p:blipFill>
         <p:spPr>
           <a:xfrm>
-            <a:off x="2502000" y="936000"/>
-            <a:ext cx="576000" cy="576000"/>
+            <a:off x="2520000" y="882000"/>
+            <a:ext cx="540000" cy="540000"/>
           </a:xfrm>
           <a:prstGeom prst="rect">
             <a:avLst/>
@@ -1965,8 +1932,8 @@
         </p:nvSpPr>
         <p:spPr>
           <a:xfrm>
-            <a:off x="2304000" y="1522800"/>
-            <a:ext cx="972000" cy="108000"/>
+            <a:off x="2376000" y="1447200"/>
+            <a:ext cx="828000" cy="93600"/>
           </a:xfrm>
           <a:prstGeom prst="rect">
             <a:avLst/>
@@ -1975,7 +1942,7 @@
           <a:ln/>
         </p:spPr>
         <p:txBody>
-          <a:bodyPr wrap="square" lIns="0" tIns="0" rIns="0" bIns="0" rtlCol="0" anchor="ctr"/>
+          <a:bodyPr wrap="square" lIns="0" tIns="0" rIns="0" bIns="0" rtlCol="0" anchor="t"/>
           <a:lstStyle/>
           <a:p>
             <a:pPr algn="ctr" indent="0" marL="0">
@@ -2001,7 +1968,7 @@
         </p:nvSpPr>
         <p:spPr>
           <a:xfrm>
-            <a:off x="252000" y="1674000"/>
+            <a:off x="252000" y="1584000"/>
             <a:ext cx="2952000" cy="0"/>
           </a:xfrm>
           <a:prstGeom prst="line">
@@ -2024,8 +1991,8 @@
         </p:nvSpPr>
         <p:spPr>
           <a:xfrm>
-            <a:off x="252000" y="1728000"/>
-            <a:ext cx="1152000" cy="180000"/>
+            <a:off x="252000" y="1656000"/>
+            <a:ext cx="1044000" cy="216000"/>
           </a:xfrm>
           <a:prstGeom prst="rect">
             <a:avLst/>
@@ -2071,8 +2038,8 @@
         </p:nvSpPr>
         <p:spPr>
           <a:xfrm>
-            <a:off x="1404000" y="1728000"/>
-            <a:ext cx="1008000" cy="180000"/>
+            <a:off x="1332000" y="1656000"/>
+            <a:ext cx="1008000" cy="216000"/>
           </a:xfrm>
           <a:prstGeom prst="rect">
             <a:avLst/>
@@ -2118,8 +2085,8 @@
         </p:nvSpPr>
         <p:spPr>
           <a:xfrm>
-            <a:off x="2376000" y="1728000"/>
-            <a:ext cx="828000" cy="180000"/>
+            <a:off x="2376000" y="1656000"/>
+            <a:ext cx="828000" cy="216000"/>
           </a:xfrm>
           <a:prstGeom prst="rect">
             <a:avLst/>

</xml_diff>

<commit_message>
Update cards B, D and E for parents with real contact data
- Copy addressed to parents (usted), monthly report for parents
- Real WhatsApp number and QR with prefilled message
- Monthly plan: 10% discount plus payment facilities
- School level limited to secundaria; full course list on the back
- Brand name Despeja; full university name, no logo

Co-Authored-By: Claude Opus 5.5 <noreply@anthropic.com>
Claude-Session: https://claude.ai/code/session_01ASinA93KsyzmhBdhUk8dLe
</commit_message>
<xml_diff>
--- a/tarjeta-clases/propuesta-B-powerpoint/tarjeta-pizarra.pptx
+++ b/tarjeta-clases/propuesta-B-powerpoint/tarjeta-pizarra.pptx
@@ -591,7 +591,7 @@
           <a:p>
             <a:r>
               <a:rPr lang="en-US" dirty="0"/>
-              <a:t>Reverso. Reemplazar TU MARCA, WhatsApp, Instagram, % de descuento y QR.</a:t>
+              <a:t>Reverso. Confirmar el usuario de Instagram antes de imprimir.</a:t>
             </a:r>
             <a:endParaRPr lang="en-US" dirty="0"/>
           </a:p>
@@ -972,7 +972,7 @@
         </p:nvSpPr>
         <p:spPr>
           <a:xfrm rot="-300000">
-            <a:off x="1800000" y="223200"/>
+            <a:off x="2484000" y="180000"/>
             <a:ext cx="792000" cy="180000"/>
           </a:xfrm>
           <a:prstGeom prst="rect">
@@ -1096,7 +1096,7 @@
         <p:spPr>
           <a:xfrm>
             <a:off x="252000" y="252000"/>
-            <a:ext cx="1440000" cy="126000"/>
+            <a:ext cx="2088000" cy="126000"/>
           </a:xfrm>
           <a:prstGeom prst="rect">
             <a:avLst/>
@@ -1117,7 +1117,7 @@
                   <a:srgbClr val="7FA796"/>
                 </a:solidFill>
               </a:rPr>
-              <a:t>Clases particulares y grupales</a:t>
+              <a:t>Clases particulares y grupales para su hijo(a)</a:t>
             </a:r>
             <a:endParaRPr lang="en-US" sz="700" dirty="0"/>
           </a:p>
@@ -1179,7 +1179,7 @@
                 <a:ea typeface="Century Schoolbook" pitchFamily="34" charset="-122"/>
                 <a:cs typeface="Century Schoolbook" pitchFamily="34" charset="-120"/>
               </a:rPr>
-              <a:t>tus dudas.</a:t>
+              <a:t>sus dudas.</a:t>
             </a:r>
             <a:endParaRPr lang="en-US" sz="2300" dirty="0"/>
           </a:p>
@@ -1194,7 +1194,7 @@
         <p:spPr>
           <a:xfrm>
             <a:off x="252000" y="1152000"/>
-            <a:ext cx="2088000" cy="252000"/>
+            <a:ext cx="2232000" cy="252000"/>
           </a:xfrm>
           <a:prstGeom prst="rect">
             <a:avLst/>
@@ -1213,16 +1213,16 @@
               <a:buNone/>
             </a:pPr>
             <a:r>
-              <a:rPr lang="en-US" sz="750" dirty="0">
+              <a:rPr lang="en-US" sz="720" b="1" dirty="0">
                 <a:solidFill>
                   <a:srgbClr val="F2F0E6">
-                    <a:alpha val="88000"/>
+                    <a:alpha val="92000"/>
                   </a:srgbClr>
                 </a:solidFill>
               </a:rPr>
-              <a:t>Matemática, Física y Química</a:t>
-            </a:r>
-            <a:endParaRPr lang="en-US" sz="750" dirty="0"/>
+              <a:t>Números y ciencias, de principio a fin</a:t>
+            </a:r>
+            <a:endParaRPr lang="en-US" sz="720" dirty="0"/>
           </a:p>
           <a:p>
             <a:pPr indent="0" marL="0">
@@ -1232,16 +1232,16 @@
               <a:buNone/>
             </a:pPr>
             <a:r>
-              <a:rPr lang="en-US" sz="750" dirty="0">
+              <a:rPr lang="en-US" sz="720" dirty="0">
                 <a:solidFill>
                   <a:srgbClr val="F2F0E6">
-                    <a:alpha val="88000"/>
+                    <a:alpha val="92000"/>
                   </a:srgbClr>
                 </a:solidFill>
               </a:rPr>
-              <a:t>Colegio, preuniversitario y universidad</a:t>
-            </a:r>
-            <a:endParaRPr lang="en-US" sz="750" dirty="0"/>
+              <a:t>Secundaria · Preuniversitario · Universidad</a:t>
+            </a:r>
+            <a:endParaRPr lang="en-US" sz="720" dirty="0"/>
           </a:p>
         </p:txBody>
       </p:sp>
@@ -1331,14 +1331,14 @@
       </p:sp>
       <p:sp>
         <p:nvSpPr>
-          <p:cNvPr id="11" name="marca (pendiente)"/>
+          <p:cNvPr id="11" name="marca"/>
           <p:cNvSpPr txBox="1"/>
           <p:nvPr/>
         </p:nvSpPr>
         <p:spPr>
           <a:xfrm>
             <a:off x="252000" y="1656000"/>
-            <a:ext cx="1440000" cy="216000"/>
+            <a:ext cx="1080000" cy="216000"/>
           </a:xfrm>
           <a:prstGeom prst="rect">
             <a:avLst/>
@@ -1354,7 +1354,7 @@
               <a:buNone/>
             </a:pPr>
             <a:r>
-              <a:rPr lang="en-US" sz="1100" b="1" dirty="0">
+              <a:rPr lang="en-US" sz="1300" b="1" dirty="0">
                 <a:solidFill>
                   <a:srgbClr val="F3D34A"/>
                 </a:solidFill>
@@ -1362,9 +1362,9 @@
                 <a:ea typeface="Century Schoolbook" pitchFamily="34" charset="-122"/>
                 <a:cs typeface="Century Schoolbook" pitchFamily="34" charset="-120"/>
               </a:rPr>
-              <a:t>TU MARCA</a:t>
-            </a:r>
-            <a:endParaRPr lang="en-US" sz="1100" dirty="0"/>
+              <a:t>Despeja</a:t>
+            </a:r>
+            <a:endParaRPr lang="en-US" sz="1300" dirty="0"/>
           </a:p>
         </p:txBody>
       </p:sp>
@@ -1376,8 +1376,8 @@
         </p:nvSpPr>
         <p:spPr>
           <a:xfrm>
-            <a:off x="1656000" y="1656000"/>
-            <a:ext cx="1548000" cy="216000"/>
+            <a:off x="1296000" y="1656000"/>
+            <a:ext cx="1908000" cy="216000"/>
           </a:xfrm>
           <a:prstGeom prst="rect">
             <a:avLst/>
@@ -1390,17 +1390,37 @@
           <a:lstStyle/>
           <a:p>
             <a:pPr algn="r" indent="0" marL="0">
-              <a:buNone/>
-            </a:pPr>
-            <a:r>
-              <a:rPr lang="en-US" sz="700" dirty="0">
+              <a:lnSpc>
+                <a:spcPct val="100000"/>
+              </a:lnSpc>
+              <a:buNone/>
+            </a:pPr>
+            <a:r>
+              <a:rPr lang="en-US" sz="650" dirty="0">
                 <a:solidFill>
                   <a:srgbClr val="F2F0E6"/>
                 </a:solidFill>
               </a:rPr>
-              <a:t>Profesores de Ingeniería PUCP</a:t>
-            </a:r>
-            <a:endParaRPr lang="en-US" sz="700" dirty="0"/>
+              <a:t>Profesores de Ingeniería de la</a:t>
+            </a:r>
+            <a:endParaRPr lang="en-US" sz="650" dirty="0"/>
+          </a:p>
+          <a:p>
+            <a:pPr algn="r" indent="0" marL="0">
+              <a:lnSpc>
+                <a:spcPct val="100000"/>
+              </a:lnSpc>
+              <a:buNone/>
+            </a:pPr>
+            <a:r>
+              <a:rPr lang="en-US" sz="650" b="1" dirty="0">
+                <a:solidFill>
+                  <a:srgbClr val="F2F0E6"/>
+                </a:solidFill>
+              </a:rPr>
+              <a:t>Pontificia Universidad Católica del Perú</a:t>
+            </a:r>
+            <a:endParaRPr lang="en-US" sz="650" dirty="0"/>
           </a:p>
         </p:txBody>
       </p:sp>
@@ -1445,7 +1465,7 @@
         <p:spPr>
           <a:xfrm>
             <a:off x="252000" y="252000"/>
-            <a:ext cx="1980000" cy="198000"/>
+            <a:ext cx="2088000" cy="198000"/>
           </a:xfrm>
           <a:prstGeom prst="rect">
             <a:avLst/>
@@ -1461,7 +1481,7 @@
               <a:buNone/>
             </a:pPr>
             <a:r>
-              <a:rPr lang="en-US" sz="1200" b="1" dirty="0">
+              <a:rPr lang="en-US" sz="1050" b="1" dirty="0">
                 <a:solidFill>
                   <a:srgbClr val="23443A"/>
                 </a:solidFill>
@@ -1469,9 +1489,9 @@
                 <a:ea typeface="Century Schoolbook" pitchFamily="34" charset="-122"/>
                 <a:cs typeface="Century Schoolbook" pitchFamily="34" charset="-120"/>
               </a:rPr>
-              <a:t>Así trabajamos</a:t>
-            </a:r>
-            <a:endParaRPr lang="en-US" sz="1200" dirty="0"/>
+              <a:t>Su hijo(a), paso a paso</a:t>
+            </a:r>
+            <a:endParaRPr lang="en-US" sz="1050" dirty="0"/>
           </a:p>
         </p:txBody>
       </p:sp>
@@ -1483,7 +1503,7 @@
         </p:nvSpPr>
         <p:spPr>
           <a:xfrm>
-            <a:off x="252000" y="576000"/>
+            <a:off x="252000" y="504000"/>
             <a:ext cx="158400" cy="158400"/>
           </a:xfrm>
           <a:prstGeom prst="ellipse">
@@ -1503,7 +1523,7 @@
         </p:nvSpPr>
         <p:spPr>
           <a:xfrm>
-            <a:off x="252000" y="576000"/>
+            <a:off x="252000" y="504000"/>
             <a:ext cx="158400" cy="158400"/>
           </a:xfrm>
           <a:prstGeom prst="rect">
@@ -1539,8 +1559,8 @@
         </p:nvSpPr>
         <p:spPr>
           <a:xfrm>
-            <a:off x="486000" y="543600"/>
-            <a:ext cx="1746000" cy="230400"/>
+            <a:off x="486000" y="471600"/>
+            <a:ext cx="1746000" cy="223200"/>
           </a:xfrm>
           <a:prstGeom prst="rect">
             <a:avLst/>
@@ -1553,9 +1573,6 @@
           <a:lstStyle/>
           <a:p>
             <a:pPr indent="0" marL="0">
-              <a:lnSpc>
-                <a:spcPct val="100000"/>
-              </a:lnSpc>
               <a:buNone/>
             </a:pPr>
             <a:r>
@@ -1570,9 +1587,6 @@
           </a:p>
           <a:p>
             <a:pPr indent="0" marL="0">
-              <a:lnSpc>
-                <a:spcPct val="100000"/>
-              </a:lnSpc>
               <a:buNone/>
             </a:pPr>
             <a:r>
@@ -1581,7 +1595,7 @@
                   <a:srgbClr val="3B4A44"/>
                 </a:solidFill>
               </a:rPr>
-              <a:t>ubicamos el tema exacto donde te trabas.</a:t>
+              <a:t>ubicamos el tema exacto donde se traba.</a:t>
             </a:r>
             <a:endParaRPr lang="en-US" sz="700" dirty="0"/>
           </a:p>
@@ -1595,7 +1609,7 @@
         </p:nvSpPr>
         <p:spPr>
           <a:xfrm>
-            <a:off x="252000" y="900000"/>
+            <a:off x="252000" y="763200"/>
             <a:ext cx="158400" cy="158400"/>
           </a:xfrm>
           <a:prstGeom prst="ellipse">
@@ -1615,7 +1629,7 @@
         </p:nvSpPr>
         <p:spPr>
           <a:xfrm>
-            <a:off x="252000" y="900000"/>
+            <a:off x="252000" y="763200"/>
             <a:ext cx="158400" cy="158400"/>
           </a:xfrm>
           <a:prstGeom prst="rect">
@@ -1651,8 +1665,8 @@
         </p:nvSpPr>
         <p:spPr>
           <a:xfrm>
-            <a:off x="486000" y="867600"/>
-            <a:ext cx="1746000" cy="230400"/>
+            <a:off x="486000" y="730800"/>
+            <a:ext cx="1746000" cy="223200"/>
           </a:xfrm>
           <a:prstGeom prst="rect">
             <a:avLst/>
@@ -1665,9 +1679,6 @@
           <a:lstStyle/>
           <a:p>
             <a:pPr indent="0" marL="0">
-              <a:lnSpc>
-                <a:spcPct val="100000"/>
-              </a:lnSpc>
               <a:buNone/>
             </a:pPr>
             <a:r>
@@ -1682,9 +1693,6 @@
           </a:p>
           <a:p>
             <a:pPr indent="0" marL="0">
-              <a:lnSpc>
-                <a:spcPct val="100000"/>
-              </a:lnSpc>
               <a:buNone/>
             </a:pPr>
             <a:r>
@@ -1693,7 +1701,7 @@
                   <a:srgbClr val="3B4A44"/>
                 </a:solidFill>
               </a:rPr>
-              <a:t>metas claras hasta tu examen.</a:t>
+              <a:t>metas claras hasta su examen.</a:t>
             </a:r>
             <a:endParaRPr lang="en-US" sz="700" dirty="0"/>
           </a:p>
@@ -1707,7 +1715,7 @@
         </p:nvSpPr>
         <p:spPr>
           <a:xfrm>
-            <a:off x="252000" y="1224000"/>
+            <a:off x="252000" y="1022400"/>
             <a:ext cx="158400" cy="158400"/>
           </a:xfrm>
           <a:prstGeom prst="ellipse">
@@ -1727,7 +1735,7 @@
         </p:nvSpPr>
         <p:spPr>
           <a:xfrm>
-            <a:off x="252000" y="1224000"/>
+            <a:off x="252000" y="1022400"/>
             <a:ext cx="158400" cy="158400"/>
           </a:xfrm>
           <a:prstGeom prst="rect">
@@ -1763,8 +1771,8 @@
         </p:nvSpPr>
         <p:spPr>
           <a:xfrm>
-            <a:off x="486000" y="1191600"/>
-            <a:ext cx="1746000" cy="230400"/>
+            <a:off x="486000" y="990000"/>
+            <a:ext cx="1746000" cy="223200"/>
           </a:xfrm>
           <a:prstGeom prst="rect">
             <a:avLst/>
@@ -1777,9 +1785,6 @@
           <a:lstStyle/>
           <a:p>
             <a:pPr indent="0" marL="0">
-              <a:lnSpc>
-                <a:spcPct val="100000"/>
-              </a:lnSpc>
               <a:buNone/>
             </a:pPr>
             <a:r>
@@ -1788,15 +1793,12 @@
                   <a:srgbClr val="23443A"/>
                 </a:solidFill>
               </a:rPr>
-              <a:t>Seguimiento</a:t>
+              <a:t>Reporte a los padres</a:t>
             </a:r>
             <a:endParaRPr lang="en-US" sz="700" dirty="0"/>
           </a:p>
           <a:p>
             <a:pPr indent="0" marL="0">
-              <a:lnSpc>
-                <a:spcPct val="100000"/>
-              </a:lnSpc>
               <a:buNone/>
             </a:pPr>
             <a:r>
@@ -1805,7 +1807,7 @@
                   <a:srgbClr val="3B4A44"/>
                 </a:solidFill>
               </a:rPr>
-              <a:t>reporte de avance para ti y tus papás.</a:t>
+              <a:t>cada mes usted sabe cómo avanza.</a:t>
             </a:r>
             <a:endParaRPr lang="en-US" sz="700" dirty="0"/>
           </a:p>
@@ -1813,7 +1815,54 @@
       </p:sp>
       <p:sp>
         <p:nvSpPr>
-          <p:cNvPr id="12" name="oferta (pendiente %)"/>
+          <p:cNvPr id="12" name="cursos detalle"/>
+          <p:cNvSpPr txBox="1"/>
+          <p:nvPr/>
+        </p:nvSpPr>
+        <p:spPr>
+          <a:xfrm>
+            <a:off x="252000" y="1310400"/>
+            <a:ext cx="1980000" cy="216000"/>
+          </a:xfrm>
+          <a:prstGeom prst="rect">
+            <a:avLst/>
+          </a:prstGeom>
+          <a:noFill/>
+          <a:ln/>
+        </p:spPr>
+        <p:txBody>
+          <a:bodyPr wrap="square" lIns="0" tIns="0" rIns="0" bIns="0" rtlCol="0" anchor="t"/>
+          <a:lstStyle/>
+          <a:p>
+            <a:pPr indent="0" marL="0">
+              <a:buNone/>
+            </a:pPr>
+            <a:r>
+              <a:rPr lang="en-US" sz="600" b="1" dirty="0">
+                <a:solidFill>
+                  <a:srgbClr val="23443A"/>
+                </a:solidFill>
+              </a:rPr>
+              <a:t>Cursos: </a:t>
+            </a:r>
+            <a:pPr indent="0" marL="0">
+              <a:buNone/>
+            </a:pPr>
+            <a:r>
+              <a:rPr lang="en-US" sz="600" dirty="0">
+                <a:solidFill>
+                  <a:srgbClr val="3B4A44"/>
+                </a:solidFill>
+              </a:rPr>
+              <a:t>Álgebra, Aritmética, Geometría, Trigonometría, Física, Química, Cálculo y cursos de Ingeniería.</a:t>
+            </a:r>
+            <a:endParaRPr lang="en-US" sz="600" dirty="0"/>
+          </a:p>
+        </p:txBody>
+      </p:sp>
+      <p:sp>
+        <p:nvSpPr>
+          <p:cNvPr id="13" name="oferta"/>
           <p:cNvSpPr/>
           <p:nvPr/>
         </p:nvSpPr>
@@ -1835,7 +1884,7 @@
       </p:sp>
       <p:sp>
         <p:nvSpPr>
-          <p:cNvPr id="13" name="Text 11"/>
+          <p:cNvPr id="14" name="Text 12"/>
           <p:cNvSpPr txBox="1"/>
           <p:nvPr/>
         </p:nvSpPr>
@@ -1863,7 +1912,7 @@
                   <a:srgbClr val="F2F0E6"/>
                 </a:solidFill>
               </a:rPr>
-              <a:t>Con plan mensual</a:t>
+              <a:t>Plan mensual</a:t>
             </a:r>
             <a:endParaRPr lang="en-US" sz="650" dirty="0"/>
           </a:p>
@@ -1872,7 +1921,7 @@
               <a:buNone/>
             </a:pPr>
             <a:r>
-              <a:rPr lang="en-US" sz="1800" b="1" dirty="0">
+              <a:rPr lang="en-US" sz="1900" b="1" dirty="0">
                 <a:solidFill>
                   <a:srgbClr val="F3D34A"/>
                 </a:solidFill>
@@ -1880,7 +1929,7 @@
                 <a:ea typeface="Century Schoolbook" pitchFamily="34" charset="-122"/>
                 <a:cs typeface="Century Schoolbook" pitchFamily="34" charset="-120"/>
               </a:rPr>
-              <a:t>−20%</a:t>
+              <a:t>10%</a:t>
             </a:r>
             <a:endParaRPr lang="en-US" sz="650" dirty="0"/>
           </a:p>
@@ -1894,7 +1943,7 @@
                   <a:srgbClr val="F2F0E6"/>
                 </a:solidFill>
               </a:rPr>
-              <a:t>en cada clase</a:t>
+              <a:t>de descuento</a:t>
             </a:r>
             <a:endParaRPr lang="en-US" sz="650" dirty="0"/>
           </a:p>
@@ -1902,7 +1951,7 @@
       </p:sp>
       <p:pic>
         <p:nvPicPr>
-          <p:cNvPr id="14" name="QR (pendiente)" descr="QR a WhatsApp">    </p:cNvPr>
+          <p:cNvPr id="15" name="QR WhatsApp" descr="QR a WhatsApp">    </p:cNvPr>
           <p:cNvPicPr>
             <a:picLocks noChangeAspect="1"/>
           </p:cNvPicPr>
@@ -1926,7 +1975,7 @@
       </p:pic>
       <p:sp>
         <p:nvSpPr>
-          <p:cNvPr id="15" name="Text 12"/>
+          <p:cNvPr id="16" name="Text 13"/>
           <p:cNvSpPr txBox="1"/>
           <p:nvPr/>
         </p:nvSpPr>
@@ -1954,7 +2003,7 @@
                   <a:srgbClr val="3E6B5A"/>
                 </a:solidFill>
               </a:rPr>
-              <a:t>Escanea y escríbenos</a:t>
+              <a:t>Escanee y escríbanos</a:t>
             </a:r>
             <a:endParaRPr lang="en-US" sz="600" dirty="0"/>
           </a:p>
@@ -1962,7 +2011,7 @@
       </p:sp>
       <p:sp>
         <p:nvSpPr>
-          <p:cNvPr id="16" name="Shape 13"/>
+          <p:cNvPr id="17" name="Shape 14"/>
           <p:cNvSpPr/>
           <p:nvPr/>
         </p:nvSpPr>
@@ -1985,14 +2034,14 @@
       </p:sp>
       <p:sp>
         <p:nvSpPr>
-          <p:cNvPr id="17" name="whatsapp (pendiente)"/>
+          <p:cNvPr id="18" name="whatsapp"/>
           <p:cNvSpPr txBox="1"/>
           <p:nvPr/>
         </p:nvSpPr>
         <p:spPr>
           <a:xfrm>
             <a:off x="252000" y="1656000"/>
-            <a:ext cx="1044000" cy="216000"/>
+            <a:ext cx="1116000" cy="216000"/>
           </a:xfrm>
           <a:prstGeom prst="rect">
             <a:avLst/>
@@ -2008,7 +2057,7 @@
               <a:buNone/>
             </a:pPr>
             <a:r>
-              <a:rPr lang="en-US" sz="700" b="1" dirty="0">
+              <a:rPr lang="en-US" sz="680" b="1" dirty="0">
                 <a:solidFill>
                   <a:srgbClr val="7FA796"/>
                 </a:solidFill>
@@ -2019,27 +2068,27 @@
               <a:buNone/>
             </a:pPr>
             <a:r>
-              <a:rPr lang="en-US" sz="700" b="1" dirty="0">
+              <a:rPr lang="en-US" sz="680" b="1" dirty="0">
                 <a:solidFill>
                   <a:srgbClr val="1D2B25"/>
                 </a:solidFill>
               </a:rPr>
-              <a:t>9XX XXX XXX</a:t>
-            </a:r>
-            <a:endParaRPr lang="en-US" sz="700" dirty="0"/>
-          </a:p>
-        </p:txBody>
-      </p:sp>
-      <p:sp>
-        <p:nvSpPr>
-          <p:cNvPr id="18" name="instagram (pendiente)"/>
+              <a:t>+51 961 956 660</a:t>
+            </a:r>
+            <a:endParaRPr lang="en-US" sz="680" dirty="0"/>
+          </a:p>
+        </p:txBody>
+      </p:sp>
+      <p:sp>
+        <p:nvSpPr>
+          <p:cNvPr id="19" name="instagram (pendiente confirmar)"/>
           <p:cNvSpPr txBox="1"/>
           <p:nvPr/>
         </p:nvSpPr>
         <p:spPr>
           <a:xfrm>
-            <a:off x="1332000" y="1656000"/>
-            <a:ext cx="1008000" cy="216000"/>
+            <a:off x="1386000" y="1656000"/>
+            <a:ext cx="1080000" cy="216000"/>
           </a:xfrm>
           <a:prstGeom prst="rect">
             <a:avLst/>
@@ -2055,7 +2104,7 @@
               <a:buNone/>
             </a:pPr>
             <a:r>
-              <a:rPr lang="en-US" sz="700" b="1" dirty="0">
+              <a:rPr lang="en-US" sz="680" b="1" dirty="0">
                 <a:solidFill>
                   <a:srgbClr val="7FA796"/>
                 </a:solidFill>
@@ -2066,27 +2115,27 @@
               <a:buNone/>
             </a:pPr>
             <a:r>
-              <a:rPr lang="en-US" sz="700" b="1" dirty="0">
+              <a:rPr lang="en-US" sz="680" b="1" dirty="0">
                 <a:solidFill>
                   <a:srgbClr val="1D2B25"/>
                 </a:solidFill>
               </a:rPr>
-              <a:t>@tu_usuario</a:t>
-            </a:r>
-            <a:endParaRPr lang="en-US" sz="700" dirty="0"/>
-          </a:p>
-        </p:txBody>
-      </p:sp>
-      <p:sp>
-        <p:nvSpPr>
-          <p:cNvPr id="19" name="grupos (pendiente)"/>
+              <a:t>@despeja.clases</a:t>
+            </a:r>
+            <a:endParaRPr lang="en-US" sz="680" dirty="0"/>
+          </a:p>
+        </p:txBody>
+      </p:sp>
+      <p:sp>
+        <p:nvSpPr>
+          <p:cNvPr id="20" name="facilidades"/>
           <p:cNvSpPr txBox="1"/>
           <p:nvPr/>
         </p:nvSpPr>
         <p:spPr>
           <a:xfrm>
-            <a:off x="2376000" y="1656000"/>
-            <a:ext cx="828000" cy="216000"/>
+            <a:off x="2484000" y="1656000"/>
+            <a:ext cx="720000" cy="216000"/>
           </a:xfrm>
           <a:prstGeom prst="rect">
             <a:avLst/>
@@ -2102,14 +2151,14 @@
               <a:buNone/>
             </a:pPr>
             <a:r>
-              <a:rPr lang="en-US" sz="650" b="1" dirty="0">
+              <a:rPr lang="en-US" sz="630" b="1" dirty="0">
                 <a:solidFill>
                   <a:srgbClr val="C9452E"/>
                 </a:solidFill>
               </a:rPr>
-              <a:t>Máx. 4 por grupo</a:t>
-            </a:r>
-            <a:endParaRPr lang="en-US" sz="650" dirty="0"/>
+              <a:t>Facilidades de pago</a:t>
+            </a:r>
+            <a:endParaRPr lang="en-US" sz="630" dirty="0"/>
           </a:p>
         </p:txBody>
       </p:sp>

</xml_diff>

<commit_message>
Split course list into secundaria/pre and university bullets
Co-Authored-By: Claude Opus 5.5 <noreply@anthropic.com>
Claude-Session: https://claude.ai/code/session_01ASinA93KsyzmhBdhUk8dLe
</commit_message>
<xml_diff>
--- a/tarjeta-clases/propuesta-B-powerpoint/tarjeta-pizarra.pptx
+++ b/tarjeta-clases/propuesta-B-powerpoint/tarjeta-pizarra.pptx
@@ -1503,7 +1503,7 @@
         </p:nvSpPr>
         <p:spPr>
           <a:xfrm>
-            <a:off x="252000" y="504000"/>
+            <a:off x="252000" y="489600"/>
             <a:ext cx="158400" cy="158400"/>
           </a:xfrm>
           <a:prstGeom prst="ellipse">
@@ -1523,7 +1523,7 @@
         </p:nvSpPr>
         <p:spPr>
           <a:xfrm>
-            <a:off x="252000" y="504000"/>
+            <a:off x="252000" y="489600"/>
             <a:ext cx="158400" cy="158400"/>
           </a:xfrm>
           <a:prstGeom prst="rect">
@@ -1559,7 +1559,7 @@
         </p:nvSpPr>
         <p:spPr>
           <a:xfrm>
-            <a:off x="486000" y="471600"/>
+            <a:off x="486000" y="457200"/>
             <a:ext cx="1746000" cy="223200"/>
           </a:xfrm>
           <a:prstGeom prst="rect">
@@ -1609,7 +1609,7 @@
         </p:nvSpPr>
         <p:spPr>
           <a:xfrm>
-            <a:off x="252000" y="763200"/>
+            <a:off x="252000" y="723600"/>
             <a:ext cx="158400" cy="158400"/>
           </a:xfrm>
           <a:prstGeom prst="ellipse">
@@ -1629,7 +1629,7 @@
         </p:nvSpPr>
         <p:spPr>
           <a:xfrm>
-            <a:off x="252000" y="763200"/>
+            <a:off x="252000" y="723600"/>
             <a:ext cx="158400" cy="158400"/>
           </a:xfrm>
           <a:prstGeom prst="rect">
@@ -1665,7 +1665,7 @@
         </p:nvSpPr>
         <p:spPr>
           <a:xfrm>
-            <a:off x="486000" y="730800"/>
+            <a:off x="486000" y="691200"/>
             <a:ext cx="1746000" cy="223200"/>
           </a:xfrm>
           <a:prstGeom prst="rect">
@@ -1715,7 +1715,7 @@
         </p:nvSpPr>
         <p:spPr>
           <a:xfrm>
-            <a:off x="252000" y="1022400"/>
+            <a:off x="252000" y="957600"/>
             <a:ext cx="158400" cy="158400"/>
           </a:xfrm>
           <a:prstGeom prst="ellipse">
@@ -1735,7 +1735,7 @@
         </p:nvSpPr>
         <p:spPr>
           <a:xfrm>
-            <a:off x="252000" y="1022400"/>
+            <a:off x="252000" y="957600"/>
             <a:ext cx="158400" cy="158400"/>
           </a:xfrm>
           <a:prstGeom prst="rect">
@@ -1771,7 +1771,7 @@
         </p:nvSpPr>
         <p:spPr>
           <a:xfrm>
-            <a:off x="486000" y="990000"/>
+            <a:off x="486000" y="925200"/>
             <a:ext cx="1746000" cy="223200"/>
           </a:xfrm>
           <a:prstGeom prst="rect">
@@ -1815,14 +1815,39 @@
       </p:sp>
       <p:sp>
         <p:nvSpPr>
-          <p:cNvPr id="12" name="cursos detalle"/>
+          <p:cNvPr id="12" name="viñeta Secundaria y pre: "/>
+          <p:cNvSpPr/>
+          <p:nvPr/>
+        </p:nvSpPr>
+        <p:spPr>
+          <a:xfrm>
+            <a:off x="262800" y="1234800"/>
+            <a:ext cx="39600" cy="39600"/>
+          </a:xfrm>
+          <a:prstGeom prst="ellipse">
+            <a:avLst/>
+          </a:prstGeom>
+          <a:solidFill>
+            <a:srgbClr val="F3D34A"/>
+          </a:solidFill>
+          <a:ln w="3175">
+            <a:solidFill>
+              <a:srgbClr val="23443A"/>
+            </a:solidFill>
+            <a:prstDash val="solid"/>
+          </a:ln>
+        </p:spPr>
+      </p:sp>
+      <p:sp>
+        <p:nvSpPr>
+          <p:cNvPr id="13" name="cursos Secundaria y pre: "/>
           <p:cNvSpPr txBox="1"/>
           <p:nvPr/>
         </p:nvSpPr>
         <p:spPr>
           <a:xfrm>
-            <a:off x="252000" y="1310400"/>
-            <a:ext cx="1980000" cy="216000"/>
+            <a:off x="345600" y="1202400"/>
+            <a:ext cx="1886400" cy="180000"/>
           </a:xfrm>
           <a:prstGeom prst="rect">
             <a:avLst/>
@@ -1843,7 +1868,7 @@
                   <a:srgbClr val="23443A"/>
                 </a:solidFill>
               </a:rPr>
-              <a:t>Cursos: </a:t>
+              <a:t>Secundaria y pre: </a:t>
             </a:r>
             <a:pPr indent="0" marL="0">
               <a:buNone/>
@@ -1854,7 +1879,7 @@
                   <a:srgbClr val="3B4A44"/>
                 </a:solidFill>
               </a:rPr>
-              <a:t>Álgebra, Aritmética, Geometría, Trigonometría, Física, Química, Cálculo y cursos de Ingeniería.</a:t>
+              <a:t>Álgebra, Aritmética, Geometría, Trigonometría, Física y Química.</a:t>
             </a:r>
             <a:endParaRPr lang="en-US" sz="600" dirty="0"/>
           </a:p>
@@ -1862,7 +1887,79 @@
       </p:sp>
       <p:sp>
         <p:nvSpPr>
-          <p:cNvPr id="13" name="oferta"/>
+          <p:cNvPr id="14" name="viñeta Universidad: "/>
+          <p:cNvSpPr/>
+          <p:nvPr/>
+        </p:nvSpPr>
+        <p:spPr>
+          <a:xfrm>
+            <a:off x="262800" y="1422000"/>
+            <a:ext cx="39600" cy="39600"/>
+          </a:xfrm>
+          <a:prstGeom prst="ellipse">
+            <a:avLst/>
+          </a:prstGeom>
+          <a:solidFill>
+            <a:srgbClr val="F3D34A"/>
+          </a:solidFill>
+          <a:ln w="3175">
+            <a:solidFill>
+              <a:srgbClr val="23443A"/>
+            </a:solidFill>
+            <a:prstDash val="solid"/>
+          </a:ln>
+        </p:spPr>
+      </p:sp>
+      <p:sp>
+        <p:nvSpPr>
+          <p:cNvPr id="15" name="cursos Universidad: "/>
+          <p:cNvSpPr txBox="1"/>
+          <p:nvPr/>
+        </p:nvSpPr>
+        <p:spPr>
+          <a:xfrm>
+            <a:off x="345600" y="1389600"/>
+            <a:ext cx="1886400" cy="180000"/>
+          </a:xfrm>
+          <a:prstGeom prst="rect">
+            <a:avLst/>
+          </a:prstGeom>
+          <a:noFill/>
+          <a:ln/>
+        </p:spPr>
+        <p:txBody>
+          <a:bodyPr wrap="square" lIns="0" tIns="0" rIns="0" bIns="0" rtlCol="0" anchor="t"/>
+          <a:lstStyle/>
+          <a:p>
+            <a:pPr indent="0" marL="0">
+              <a:buNone/>
+            </a:pPr>
+            <a:r>
+              <a:rPr lang="en-US" sz="600" b="1" dirty="0">
+                <a:solidFill>
+                  <a:srgbClr val="23443A"/>
+                </a:solidFill>
+              </a:rPr>
+              <a:t>Universidad: </a:t>
+            </a:r>
+            <a:pPr indent="0" marL="0">
+              <a:buNone/>
+            </a:pPr>
+            <a:r>
+              <a:rPr lang="en-US" sz="600" dirty="0">
+                <a:solidFill>
+                  <a:srgbClr val="3B4A44"/>
+                </a:solidFill>
+              </a:rPr>
+              <a:t>Cálculo, Física, Química y cursos de Ingeniería.</a:t>
+            </a:r>
+            <a:endParaRPr lang="en-US" sz="600" dirty="0"/>
+          </a:p>
+        </p:txBody>
+      </p:sp>
+      <p:sp>
+        <p:nvSpPr>
+          <p:cNvPr id="16" name="oferta"/>
           <p:cNvSpPr/>
           <p:nvPr/>
         </p:nvSpPr>
@@ -1884,7 +1981,7 @@
       </p:sp>
       <p:sp>
         <p:nvSpPr>
-          <p:cNvPr id="14" name="Text 12"/>
+          <p:cNvPr id="17" name="Text 15"/>
           <p:cNvSpPr txBox="1"/>
           <p:nvPr/>
         </p:nvSpPr>
@@ -1951,7 +2048,7 @@
       </p:sp>
       <p:pic>
         <p:nvPicPr>
-          <p:cNvPr id="15" name="QR WhatsApp" descr="QR a WhatsApp">    </p:cNvPr>
+          <p:cNvPr id="18" name="QR WhatsApp" descr="QR a WhatsApp">    </p:cNvPr>
           <p:cNvPicPr>
             <a:picLocks noChangeAspect="1"/>
           </p:cNvPicPr>
@@ -1975,7 +2072,7 @@
       </p:pic>
       <p:sp>
         <p:nvSpPr>
-          <p:cNvPr id="16" name="Text 13"/>
+          <p:cNvPr id="19" name="Text 16"/>
           <p:cNvSpPr txBox="1"/>
           <p:nvPr/>
         </p:nvSpPr>
@@ -2011,7 +2108,7 @@
       </p:sp>
       <p:sp>
         <p:nvSpPr>
-          <p:cNvPr id="17" name="Shape 14"/>
+          <p:cNvPr id="20" name="Shape 17"/>
           <p:cNvSpPr/>
           <p:nvPr/>
         </p:nvSpPr>
@@ -2034,7 +2131,7 @@
       </p:sp>
       <p:sp>
         <p:nvSpPr>
-          <p:cNvPr id="18" name="whatsapp"/>
+          <p:cNvPr id="21" name="whatsapp"/>
           <p:cNvSpPr txBox="1"/>
           <p:nvPr/>
         </p:nvSpPr>
@@ -2081,7 +2178,7 @@
       </p:sp>
       <p:sp>
         <p:nvSpPr>
-          <p:cNvPr id="19" name="instagram (pendiente confirmar)"/>
+          <p:cNvPr id="22" name="instagram (pendiente confirmar)"/>
           <p:cNvSpPr txBox="1"/>
           <p:nvPr/>
         </p:nvSpPr>
@@ -2128,7 +2225,7 @@
       </p:sp>
       <p:sp>
         <p:nvSpPr>
-          <p:cNvPr id="20" name="facilidades"/>
+          <p:cNvPr id="23" name="facilidades"/>
           <p:cNvSpPr txBox="1"/>
           <p:nvPr/>
         </p:nvSpPr>

</xml_diff>